<commit_message>
Make every deck valid PresentationML: schema order in presentation.xml, one paragraph property per paragraph
Checked with the ISO/IEC 29500 PresentationML schema: 449 of 450 decks and all 428 decks inside the zip files are valid
(the old Quran deck uses a markup-compatibility Morph transition, which the base schema does not cover). post.py and
game_post.py now fix their output automatically.

Co-Authored-By: Claude Opus 5.5 <noreply@anthropic.com>
Claude-Session: https://claude.ai/code/session_01XjTEwQ8YdBa1SjcPiYTm9z
</commit_message>
<xml_diff>
--- a/PowerPoint_Presentations/003-Ghunnah-on-Doubled-Noon.pptx
+++ b/PowerPoint_Presentations/003-Ghunnah-on-Doubled-Noon.pptx
@@ -4,6 +4,9 @@
   <p:sldMasterIdLst>
     <p:sldMasterId id="2147483648" r:id="rId1"/>
   </p:sldMasterIdLst>
+  <p:notesMasterIdLst>
+    <p:notesMasterId r:id="rId34"/>
+  </p:notesMasterIdLst>
   <p:sldIdLst>
     <p:sldId id="256" r:id="rId2"/>
     <p:sldId id="257" r:id="rId3"/>
@@ -38,9 +41,6 @@
     <p:sldId id="286" r:id="rId32"/>
     <p:sldId id="287" r:id="rId33"/>
   </p:sldIdLst>
-  <p:notesMasterIdLst>
-    <p:notesMasterId r:id="rId34"/>
-  </p:notesMasterIdLst>
   <p:sldSz cx="12192000" cy="6858000"/>
   <p:notesSz cx="6858000" cy="12192000"/>
   <p:defaultTextStyle>
@@ -4703,9 +4703,6 @@
               </a:rPr>
               <a:t>مِنَ </a:t>
             </a:r>
-            <a:pPr algn="ctr" indent="0" marL="0">
-              <a:buNone/>
-            </a:pPr>
             <a:r>
               <a:rPr lang="ar-SA" altLang="en-US" sz="6600" dirty="0">
                 <a:solidFill>
@@ -4720,9 +4717,6 @@
               </a:rPr>
               <a:t>ٱلْجِنَّةِ</a:t>
             </a:r>
-            <a:pPr algn="ctr" indent="0" marL="0">
-              <a:buNone/>
-            </a:pPr>
             <a:r>
               <a:rPr lang="ar-SA" altLang="en-US" sz="6600" dirty="0">
                 <a:solidFill>
@@ -4734,9 +4728,6 @@
               </a:rPr>
               <a:t> وَ</a:t>
             </a:r>
-            <a:pPr algn="ctr" indent="0" marL="0">
-              <a:buNone/>
-            </a:pPr>
             <a:r>
               <a:rPr lang="ar-SA" altLang="en-US" sz="6600" dirty="0">
                 <a:solidFill>
@@ -5762,9 +5753,6 @@
               </a:rPr>
               <a:t>إِنَّ</a:t>
             </a:r>
-            <a:pPr algn="ctr" indent="0" marL="0">
-              <a:buNone/>
-            </a:pPr>
             <a:r>
               <a:rPr lang="ar-SA" altLang="en-US" sz="6600" dirty="0">
                 <a:solidFill>
@@ -8623,9 +8611,6 @@
               </a:rPr>
               <a:t>مِنَ </a:t>
             </a:r>
-            <a:pPr algn="ctr" indent="0" marL="0">
-              <a:buNone/>
-            </a:pPr>
             <a:r>
               <a:rPr lang="ar-SA" altLang="en-US" sz="6000" dirty="0">
                 <a:solidFill>
@@ -8637,9 +8622,6 @@
               </a:rPr>
               <a:t>ٱلْجِنَّةِ</a:t>
             </a:r>
-            <a:pPr algn="ctr" indent="0" marL="0">
-              <a:buNone/>
-            </a:pPr>
             <a:r>
               <a:rPr lang="ar-SA" altLang="en-US" sz="6000" dirty="0">
                 <a:solidFill>
@@ -8651,9 +8633,6 @@
               </a:rPr>
               <a:t> وَ</a:t>
             </a:r>
-            <a:pPr algn="ctr" indent="0" marL="0">
-              <a:buNone/>
-            </a:pPr>
             <a:r>
               <a:rPr lang="ar-SA" altLang="en-US" sz="6000" dirty="0">
                 <a:solidFill>
@@ -9559,9 +9538,6 @@
               </a:rPr>
               <a:t>مِنَ </a:t>
             </a:r>
-            <a:pPr algn="ctr" indent="0" marL="0">
-              <a:buNone/>
-            </a:pPr>
             <a:r>
               <a:rPr lang="ar-SA" altLang="en-US" sz="6000" dirty="0">
                 <a:solidFill>
@@ -9576,9 +9552,6 @@
               </a:rPr>
               <a:t>ٱلْجِنَّةِ</a:t>
             </a:r>
-            <a:pPr algn="ctr" indent="0" marL="0">
-              <a:buNone/>
-            </a:pPr>
             <a:r>
               <a:rPr lang="ar-SA" altLang="en-US" sz="6000" dirty="0">
                 <a:solidFill>
@@ -9590,9 +9563,6 @@
               </a:rPr>
               <a:t> وَ</a:t>
             </a:r>
-            <a:pPr algn="ctr" indent="0" marL="0">
-              <a:buNone/>
-            </a:pPr>
             <a:r>
               <a:rPr lang="ar-SA" altLang="en-US" sz="6000" dirty="0">
                 <a:solidFill>
@@ -9761,9 +9731,6 @@
               </a:rPr>
               <a:t>Extra challenge  </a:t>
             </a:r>
-            <a:pPr indent="0" marL="0">
-              <a:buNone/>
-            </a:pPr>
             <a:r>
               <a:rPr lang="en-US" sz="2100" dirty="0">
                 <a:solidFill>
@@ -10062,9 +10029,6 @@
               </a:rPr>
               <a:t>مِنَ </a:t>
             </a:r>
-            <a:pPr algn="ctr" indent="0" marL="0">
-              <a:buNone/>
-            </a:pPr>
             <a:r>
               <a:rPr lang="ar-SA" altLang="en-US" sz="6000" dirty="0">
                 <a:solidFill>
@@ -10079,9 +10043,6 @@
               </a:rPr>
               <a:t>ٱلْجِنَّةِ</a:t>
             </a:r>
-            <a:pPr algn="ctr" indent="0" marL="0">
-              <a:buNone/>
-            </a:pPr>
             <a:r>
               <a:rPr lang="ar-SA" altLang="en-US" sz="6000" dirty="0">
                 <a:solidFill>
@@ -10093,9 +10054,6 @@
               </a:rPr>
               <a:t> وَ</a:t>
             </a:r>
-            <a:pPr algn="ctr" indent="0" marL="0">
-              <a:buNone/>
-            </a:pPr>
             <a:r>
               <a:rPr lang="ar-SA" altLang="en-US" sz="6000" dirty="0">
                 <a:solidFill>
@@ -10469,9 +10427,6 @@
               </a:rPr>
               <a:t>مِنَ</a:t>
             </a:r>
-            <a:pPr algn="ctr" indent="0" marL="0">
-              <a:buNone/>
-            </a:pPr>
             <a:r>
               <a:rPr lang="ar-SA" altLang="en-US" sz="6000" dirty="0">
                 <a:solidFill>
@@ -10920,9 +10875,6 @@
               </a:rPr>
               <a:t>إِنَّ</a:t>
             </a:r>
-            <a:pPr algn="ctr" indent="0" marL="0">
-              <a:buNone/>
-            </a:pPr>
             <a:r>
               <a:rPr lang="ar-SA" altLang="en-US" sz="6000" dirty="0">
                 <a:solidFill>
@@ -11117,9 +11069,6 @@
               </a:rPr>
               <a:t>إِ</a:t>
             </a:r>
-            <a:pPr algn="ctr" indent="0" marL="0">
-              <a:buNone/>
-            </a:pPr>
             <a:r>
               <a:rPr lang="ar-SA" altLang="en-US" sz="4200" dirty="0">
                 <a:solidFill>
@@ -11278,9 +11227,6 @@
               </a:rPr>
               <a:t>ٱ</a:t>
             </a:r>
-            <a:pPr algn="ctr" indent="0" marL="0">
-              <a:buNone/>
-            </a:pPr>
             <a:r>
               <a:rPr lang="ar-SA" altLang="en-US" sz="4200" dirty="0">
                 <a:solidFill>
@@ -11295,9 +11241,6 @@
               </a:rPr>
               <a:t>لَّ</a:t>
             </a:r>
-            <a:pPr algn="ctr" indent="0" marL="0">
-              <a:buNone/>
-            </a:pPr>
             <a:r>
               <a:rPr lang="ar-SA" altLang="en-US" sz="4200" dirty="0">
                 <a:solidFill>
@@ -11453,9 +11396,6 @@
               </a:rPr>
               <a:t>ٱلَّذِي</a:t>
             </a:r>
-            <a:pPr algn="ctr" indent="0" marL="0">
-              <a:buNone/>
-            </a:pPr>
             <a:r>
               <a:rPr lang="ar-SA" altLang="en-US" sz="4200" dirty="0">
                 <a:solidFill>
@@ -12019,9 +11959,6 @@
               </a:rPr>
               <a:t>إِنَّ</a:t>
             </a:r>
-            <a:pPr algn="ctr" indent="0" marL="0">
-              <a:buNone/>
-            </a:pPr>
             <a:r>
               <a:rPr lang="ar-SA" altLang="en-US" sz="6000" dirty="0">
                 <a:solidFill>
@@ -12187,9 +12124,6 @@
               </a:rPr>
               <a:t>Extra challenge  </a:t>
             </a:r>
-            <a:pPr indent="0" marL="0">
-              <a:buNone/>
-            </a:pPr>
             <a:r>
               <a:rPr lang="en-US" sz="2100" dirty="0">
                 <a:solidFill>
@@ -14221,9 +14155,6 @@
               </a:rPr>
               <a:t>إِنَّ ٱ</a:t>
             </a:r>
-            <a:pPr algn="ctr" indent="0" marL="0">
-              <a:buNone/>
-            </a:pPr>
             <a:r>
               <a:rPr lang="ar-SA" altLang="en-US" sz="6000" dirty="0">
                 <a:solidFill>
@@ -14238,9 +14169,6 @@
               </a:rPr>
               <a:t>لَّ</a:t>
             </a:r>
-            <a:pPr algn="ctr" indent="0" marL="0">
-              <a:buNone/>
-            </a:pPr>
             <a:r>
               <a:rPr lang="ar-SA" altLang="en-US" sz="6000" dirty="0">
                 <a:solidFill>
@@ -14611,9 +14539,6 @@
               </a:rPr>
               <a:t>إِنَّ ٱلَّذِي</a:t>
             </a:r>
-            <a:pPr algn="ctr" indent="0" marL="0">
-              <a:buNone/>
-            </a:pPr>
             <a:r>
               <a:rPr lang="ar-SA" altLang="en-US" sz="6000" dirty="0">
                 <a:solidFill>
@@ -15849,9 +15774,6 @@
               </a:rPr>
               <a:t>Extra challenge  </a:t>
             </a:r>
-            <a:pPr indent="0" marL="0">
-              <a:buNone/>
-            </a:pPr>
             <a:r>
               <a:rPr lang="en-US" sz="2100" dirty="0">
                 <a:solidFill>
@@ -16153,9 +16075,6 @@
               </a:rPr>
               <a:t>مِنَ</a:t>
             </a:r>
-            <a:pPr algn="ctr" indent="0" marL="0">
-              <a:buNone/>
-            </a:pPr>
             <a:r>
               <a:rPr lang="ar-SA" altLang="en-US" sz="6000" dirty="0">
                 <a:solidFill>
@@ -16167,9 +16086,6 @@
               </a:rPr>
               <a:t>   ·   </a:t>
             </a:r>
-            <a:pPr algn="ctr" indent="0" marL="0">
-              <a:buNone/>
-            </a:pPr>
             <a:r>
               <a:rPr lang="ar-SA" altLang="en-US" sz="6000" dirty="0">
                 <a:solidFill>
@@ -17508,9 +17424,6 @@
               </a:rPr>
               <a:t>Extra challenge  </a:t>
             </a:r>
-            <a:pPr indent="0" marL="0">
-              <a:buNone/>
-            </a:pPr>
             <a:r>
               <a:rPr lang="en-US" sz="2100" dirty="0">
                 <a:solidFill>
@@ -21190,6 +21103,20 @@
               </a:rPr>
               <a:t>Timing  </a:t>
             </a:r>
+            <a:r>
+              <a:rPr lang="en-US" sz="2200" dirty="0">
+                <a:solidFill>
+                  <a:srgbClr val="16302E"/>
+                </a:solidFill>
+                <a:latin typeface="Calibri" pitchFamily="34" charset="0"/>
+                <a:ea typeface="Calibri" pitchFamily="34" charset="-122"/>
+                <a:cs typeface="Calibri" pitchFamily="34" charset="-120"/>
+              </a:rPr>
+              <a:t>Two counts, measured against two short vowels at your current recitation speed; relative to pace, not fixed seconds.</a:t>
+            </a:r>
+            <a:endParaRPr lang="en-US" sz="2200" dirty="0"/>
+          </a:p>
+          <a:p>
             <a:pPr indent="0" marL="0">
               <a:spcAft>
                 <a:spcPts val="800"/>
@@ -21197,26 +21124,6 @@
               <a:buNone/>
             </a:pPr>
             <a:r>
-              <a:rPr lang="en-US" sz="2200" dirty="0">
-                <a:solidFill>
-                  <a:srgbClr val="16302E"/>
-                </a:solidFill>
-                <a:latin typeface="Calibri" pitchFamily="34" charset="0"/>
-                <a:ea typeface="Calibri" pitchFamily="34" charset="-122"/>
-                <a:cs typeface="Calibri" pitchFamily="34" charset="-120"/>
-              </a:rPr>
-              <a:t>Two counts, measured against two short vowels at your current recitation speed; relative to pace, not fixed seconds.</a:t>
-            </a:r>
-            <a:endParaRPr lang="en-US" sz="2200" dirty="0"/>
-          </a:p>
-          <a:p>
-            <a:pPr indent="0" marL="0">
-              <a:spcAft>
-                <a:spcPts val="800"/>
-              </a:spcAft>
-              <a:buNone/>
-            </a:pPr>
-            <a:r>
               <a:rPr lang="en-US" sz="2200" b="1" dirty="0">
                 <a:solidFill>
                   <a:srgbClr val="0F5148"/>
@@ -21227,12 +21134,6 @@
               </a:rPr>
               <a:t>Demonstrate  </a:t>
             </a:r>
-            <a:pPr indent="0" marL="0">
-              <a:spcAft>
-                <a:spcPts val="800"/>
-              </a:spcAft>
-              <a:buNone/>
-            </a:pPr>
             <a:r>
               <a:rPr lang="en-US" sz="2200" dirty="0">
                 <a:solidFill>
@@ -22893,6 +22794,20 @@
               </a:rPr>
               <a:t>Source: </a:t>
             </a:r>
+            <a:r>
+              <a:rPr lang="en-US" sz="1600" dirty="0">
+                <a:solidFill>
+                  <a:srgbClr val="2C4744"/>
+                </a:solidFill>
+                <a:latin typeface="Calibri" pitchFamily="34" charset="0"/>
+                <a:ea typeface="Calibri" pitchFamily="34" charset="-122"/>
+                <a:cs typeface="Calibri" pitchFamily="34" charset="-120"/>
+              </a:rPr>
+              <a:t>Tajweed1.pdf, PDF page 11 (page positions include covers).</a:t>
+            </a:r>
+            <a:endParaRPr lang="en-US" sz="1600" dirty="0"/>
+          </a:p>
+          <a:p>
             <a:pPr indent="0" marL="0">
               <a:spcAft>
                 <a:spcPts val="800"/>
@@ -22900,6 +22815,17 @@
               <a:buNone/>
             </a:pPr>
             <a:r>
+              <a:rPr lang="en-US" sz="1600" b="1" dirty="0">
+                <a:solidFill>
+                  <a:srgbClr val="2C4744"/>
+                </a:solidFill>
+                <a:latin typeface="Calibri" pitchFamily="34" charset="0"/>
+                <a:ea typeface="Calibri" pitchFamily="34" charset="-122"/>
+                <a:cs typeface="Calibri" pitchFamily="34" charset="-120"/>
+              </a:rPr>
+              <a:t>Reading: </a:t>
+            </a:r>
+            <a:r>
               <a:rPr lang="en-US" sz="1600" dirty="0">
                 <a:solidFill>
                   <a:srgbClr val="2C4744"/>
@@ -22908,7 +22834,7 @@
                 <a:ea typeface="Calibri" pitchFamily="34" charset="-122"/>
                 <a:cs typeface="Calibri" pitchFamily="34" charset="-120"/>
               </a:rPr>
-              <a:t>Tajweed1.pdf, PDF page 11 (page positions include covers).</a:t>
+              <a:t>Hafs through Shatibiyyah, as stated in the source.</a:t>
             </a:r>
             <a:endParaRPr lang="en-US" sz="1600" dirty="0"/>
           </a:p>
@@ -22928,8 +22854,22 @@
                 <a:ea typeface="Calibri" pitchFamily="34" charset="-122"/>
                 <a:cs typeface="Calibri" pitchFamily="34" charset="-120"/>
               </a:rPr>
-              <a:t>Reading: </a:t>
-            </a:r>
+              <a:t>Excerpts: </a:t>
+            </a:r>
+            <a:r>
+              <a:rPr lang="en-US" sz="1600" dirty="0">
+                <a:solidFill>
+                  <a:srgbClr val="2C4744"/>
+                </a:solidFill>
+                <a:latin typeface="Calibri" pitchFamily="34" charset="0"/>
+                <a:ea typeface="Calibri" pitchFamily="34" charset="-122"/>
+                <a:cs typeface="Calibri" pitchFamily="34" charset="-120"/>
+              </a:rPr>
+              <a:t>114:6 and 2:6 (opening words), checked by the source against the Uthmani text (alquran.cloud).</a:t>
+            </a:r>
+            <a:endParaRPr lang="en-US" sz="1600" dirty="0"/>
+          </a:p>
+          <a:p>
             <a:pPr indent="0" marL="0">
               <a:spcAft>
                 <a:spcPts val="800"/>
@@ -22937,7 +22877,7 @@
               <a:buNone/>
             </a:pPr>
             <a:r>
-              <a:rPr lang="en-US" sz="1600" dirty="0">
+              <a:rPr lang="en-US" sz="1600" b="1" dirty="0">
                 <a:solidFill>
                   <a:srgbClr val="2C4744"/>
                 </a:solidFill>
@@ -22945,71 +22885,8 @@
                 <a:ea typeface="Calibri" pitchFamily="34" charset="-122"/>
                 <a:cs typeface="Calibri" pitchFamily="34" charset="-120"/>
               </a:rPr>
-              <a:t>Hafs through Shatibiyyah, as stated in the source.</a:t>
-            </a:r>
-            <a:endParaRPr lang="en-US" sz="1600" dirty="0"/>
-          </a:p>
-          <a:p>
-            <a:pPr indent="0" marL="0">
-              <a:spcAft>
-                <a:spcPts val="800"/>
-              </a:spcAft>
-              <a:buNone/>
-            </a:pPr>
-            <a:r>
-              <a:rPr lang="en-US" sz="1600" b="1" dirty="0">
-                <a:solidFill>
-                  <a:srgbClr val="2C4744"/>
-                </a:solidFill>
-                <a:latin typeface="Calibri" pitchFamily="34" charset="0"/>
-                <a:ea typeface="Calibri" pitchFamily="34" charset="-122"/>
-                <a:cs typeface="Calibri" pitchFamily="34" charset="-120"/>
-              </a:rPr>
-              <a:t>Excerpts: </a:t>
-            </a:r>
-            <a:pPr indent="0" marL="0">
-              <a:spcAft>
-                <a:spcPts val="800"/>
-              </a:spcAft>
-              <a:buNone/>
-            </a:pPr>
-            <a:r>
-              <a:rPr lang="en-US" sz="1600" dirty="0">
-                <a:solidFill>
-                  <a:srgbClr val="2C4744"/>
-                </a:solidFill>
-                <a:latin typeface="Calibri" pitchFamily="34" charset="0"/>
-                <a:ea typeface="Calibri" pitchFamily="34" charset="-122"/>
-                <a:cs typeface="Calibri" pitchFamily="34" charset="-120"/>
-              </a:rPr>
-              <a:t>114:6 and 2:6 (opening words), checked by the source against the Uthmani text (alquran.cloud).</a:t>
-            </a:r>
-            <a:endParaRPr lang="en-US" sz="1600" dirty="0"/>
-          </a:p>
-          <a:p>
-            <a:pPr indent="0" marL="0">
-              <a:spcAft>
-                <a:spcPts val="800"/>
-              </a:spcAft>
-              <a:buNone/>
-            </a:pPr>
-            <a:r>
-              <a:rPr lang="en-US" sz="1600" b="1" dirty="0">
-                <a:solidFill>
-                  <a:srgbClr val="2C4744"/>
-                </a:solidFill>
-                <a:latin typeface="Calibri" pitchFamily="34" charset="0"/>
-                <a:ea typeface="Calibri" pitchFamily="34" charset="-122"/>
-                <a:cs typeface="Calibri" pitchFamily="34" charset="-120"/>
-              </a:rPr>
               <a:t>Teaching package: </a:t>
             </a:r>
-            <a:pPr indent="0" marL="0">
-              <a:spcAft>
-                <a:spcPts val="800"/>
-              </a:spcAft>
-              <a:buNone/>
-            </a:pPr>
             <a:r>
               <a:rPr lang="en-US" sz="1600" dirty="0">
                 <a:solidFill>
@@ -28730,9 +28607,6 @@
               </a:rPr>
               <a:t>Keep it accurate  </a:t>
             </a:r>
-            <a:pPr indent="0" marL="0">
-              <a:buNone/>
-            </a:pPr>
             <a:r>
               <a:rPr lang="en-US" sz="1900" dirty="0">
                 <a:solidFill>

</xml_diff>